<commit_message>
feat: text 2nd technique (zero-width), metadata CLI/GUI polish, 17-slide presentation, docs 60/60
</commit_message>
<xml_diff>
--- a/StegoNexus_Presentation.pptx
+++ b/StegoNexus_Presentation.pptx
@@ -21,6 +21,7 @@
     <p:sldId id="269" r:id="rId20"/>
     <p:sldId id="270" r:id="rId21"/>
     <p:sldId id="271" r:id="rId22"/>
+    <p:sldId id="272" r:id="rId23"/>
   </p:sldIdLst>
   <p:sldSz cx="12191695" cy="6858000" type="screen4x3"/>
   <p:notesSz cx="6858000" cy="9144000"/>
@@ -3371,7 +3372,7 @@
                 </a:solidFill>
                 <a:latin typeface="Segoe UI"/>
               </a:rPr>
-              <a:t>إخفاء الفيديو — VideoHide</a:t>
+              <a:t>إخفاء الصوت</a:t>
             </a:r>
           </a:p>
           <a:p>
@@ -3387,7 +3388,7 @@
                 </a:solidFill>
                 <a:latin typeface="Segoe UI"/>
               </a:rPr>
-              <a:t>Video Hiding</a:t>
+              <a:t>Audio Hiding</a:t>
             </a:r>
           </a:p>
         </p:txBody>
@@ -3439,7 +3440,7 @@
                   <a:srgbClr val="08130D"/>
                 </a:solidFill>
               </a:rPr>
-              <a:t>07</a:t>
+              <a:t>06</a:t>
             </a:r>
           </a:p>
         </p:txBody>
@@ -3496,8 +3497,8 @@
         </p:nvSpPr>
         <p:spPr>
           <a:xfrm>
-            <a:off x="731520" y="1417320"/>
-            <a:ext cx="10698480" cy="1920240"/>
+            <a:off x="731520" y="1371600"/>
+            <a:ext cx="10698480" cy="731520"/>
           </a:xfrm>
           <a:prstGeom prst="rect">
             <a:avLst/>
@@ -3512,88 +3513,127 @@
           <a:p>
             <a:pPr algn="l">
               <a:spcAft>
-                <a:spcPts val="1000"/>
-              </a:spcAft>
-            </a:pPr>
-            <a:r>
-              <a:rPr sz="1500" b="0">
+                <a:spcPts val="600"/>
+              </a:spcAft>
+            </a:pPr>
+            <a:r>
+              <a:rPr sz="1500" b="1">
                 <a:solidFill>
                   <a:srgbClr val="E6E6E6"/>
                 </a:solidFill>
                 <a:latin typeface="Segoe UI"/>
               </a:rPr>
-              <a:t>• لا يعتمد على برنامج جاهز واحد: VideoHide module + سكريبت videohide.sh + FFmpeg + FFprobe</a:t>
-            </a:r>
-          </a:p>
-          <a:p>
-            <a:pPr algn="l">
-              <a:spcAft>
-                <a:spcPts val="1000"/>
-              </a:spcAft>
-            </a:pPr>
-            <a:r>
-              <a:rPr sz="1500" b="0">
+              <a:t>أربع تقنيات رئيسية (أكثر من تقنية في نفس الموضوع — حسب المتطلبات):</a:t>
+            </a:r>
+          </a:p>
+        </p:txBody>
+      </p:sp>
+      <p:sp>
+        <p:nvSpPr>
+          <p:cNvPr id="7" name="TextBox 6"/>
+          <p:cNvSpPr txBox="1"/>
+          <p:nvPr/>
+        </p:nvSpPr>
+        <p:spPr>
+          <a:xfrm>
+            <a:off x="731520" y="2"/>
+            <a:ext cx="10698480" cy="1920240"/>
+          </a:xfrm>
+          <a:prstGeom prst="rect">
+            <a:avLst/>
+          </a:prstGeom>
+          <a:noFill/>
+        </p:spPr>
+        <p:txBody>
+          <a:bodyPr wrap="square" anchor="t">
+            <a:spAutoFit/>
+          </a:bodyPr>
+          <a:lstStyle/>
+          <a:p>
+            <a:pPr algn="l">
+              <a:spcAft>
+                <a:spcPts val="800"/>
+              </a:spcAft>
+            </a:pPr>
+            <a:r>
+              <a:rPr sz="1400" b="0">
                 <a:solidFill>
                   <a:srgbClr val="E6E6E6"/>
                 </a:solidFill>
                 <a:latin typeface="Segoe UI"/>
               </a:rPr>
-              <a:t>• Video LSB  — تعديل LSB في المسار الصوتي للفيديو مع نسخ الإطارات البصرية كما هي (-c:v copy) → صفر تغيير بصري</a:t>
-            </a:r>
-          </a:p>
-          <a:p>
-            <a:pPr algn="l">
-              <a:spcAft>
-                <a:spcPts val="1000"/>
-              </a:spcAft>
-            </a:pPr>
-            <a:r>
-              <a:rPr sz="1500" b="0">
+              <a:t>• LSB  — إخفاء البيانات داخل Least Significant Bits لعينات الصوت (تبديل مواضع بالمفتاح)</a:t>
+            </a:r>
+          </a:p>
+          <a:p>
+            <a:pPr algn="l">
+              <a:spcAft>
+                <a:spcPts val="800"/>
+              </a:spcAft>
+            </a:pPr>
+            <a:r>
+              <a:rPr sz="1400" b="0">
                 <a:solidFill>
                   <a:srgbClr val="E6E6E6"/>
                 </a:solidFill>
                 <a:latin typeface="Segoe UI"/>
               </a:rPr>
-              <a:t>• Container / File Hiding  — استغلال ملف الفيديو لإخفاء بيانات إضافية (حمولة مشفّرة + تذييل موقّع)</a:t>
-            </a:r>
-          </a:p>
-          <a:p>
-            <a:pPr algn="l">
-              <a:spcAft>
-                <a:spcPts val="1000"/>
-              </a:spcAft>
-            </a:pPr>
-            <a:r>
-              <a:rPr sz="1500" b="0">
+              <a:t>• Phase Coding  — تعديل معلومات الـ Phase (فرق ±π/2 بين إطارات FFT متتالية)</a:t>
+            </a:r>
+          </a:p>
+          <a:p>
+            <a:pPr algn="l">
+              <a:spcAft>
+                <a:spcPts val="800"/>
+              </a:spcAft>
+            </a:pPr>
+            <a:r>
+              <a:rPr sz="1400" b="0">
                 <a:solidFill>
                   <a:srgbClr val="E6E6E6"/>
                 </a:solidFill>
                 <a:latin typeface="Segoe UI"/>
               </a:rPr>
-              <a:t>• Spread Spectrum  — نشر البيانات داخل معلومات الفيديو (DSSS على المسار الصوتي)</a:t>
-            </a:r>
-          </a:p>
-          <a:p>
-            <a:pPr algn="l">
-              <a:spcAft>
-                <a:spcPts val="1000"/>
-              </a:spcAft>
-            </a:pPr>
-            <a:r>
-              <a:rPr sz="1500" b="0">
+              <a:t>• Spread Spectrum  — نشر البيانات على نطاق ترددات بدل موضع واحد (DSSS-BPSK)</a:t>
+            </a:r>
+          </a:p>
+          <a:p>
+            <a:pPr algn="l">
+              <a:spcAft>
+                <a:spcPts val="800"/>
+              </a:spcAft>
+            </a:pPr>
+            <a:r>
+              <a:rPr sz="1400" b="0">
                 <a:solidFill>
                   <a:srgbClr val="E6E6E6"/>
                 </a:solidFill>
                 <a:latin typeface="Segoe UI"/>
               </a:rPr>
-              <a:t>• التحليل: ffprobe يعرض الـ Streams (codec / bitrate / duration), FFmpeg يستخرج ويعيد ترميز الصوت</a:t>
+              <a:t>• Metadata  — إخفاء البيانات داخل الملف الصوتي دون تعديل العينات (RIFF LIST-INFO / ICMT)</a:t>
+            </a:r>
+          </a:p>
+          <a:p>
+            <a:pPr algn="l">
+              <a:spcAft>
+                <a:spcPts val="800"/>
+              </a:spcAft>
+            </a:pPr>
+            <a:r>
+              <a:rPr sz="1400" b="0">
+                <a:solidFill>
+                  <a:srgbClr val="E6E6E6"/>
+                </a:solidFill>
+                <a:latin typeface="Segoe UI"/>
+              </a:rPr>
+              <a:t>• التحليل: Steghide (للحالات التي يدعمها) + Spectrogram Frequency Analysis و Waveform (مخرجات Audacity)</a:t>
             </a:r>
           </a:p>
         </p:txBody>
       </p:sp>
       <p:pic>
         <p:nvPicPr>
-          <p:cNvPr id="7" name="Picture 6" descr="07_video_hiding.png"/>
+          <p:cNvPr id="8" name="Picture 7" descr="06_audio_hiding.png"/>
           <p:cNvPicPr>
             <a:picLocks noChangeAspect="1"/>
           </p:cNvPicPr>
@@ -3607,8 +3647,8 @@
         </p:blipFill>
         <p:spPr>
           <a:xfrm>
-            <a:off x="731520" y="4297680"/>
-            <a:ext cx="5303520" cy="3305092"/>
+            <a:off x="731520" y="4709160"/>
+            <a:ext cx="5212080" cy="3248108"/>
           </a:xfrm>
           <a:prstGeom prst="rect">
             <a:avLst/>
@@ -3711,7 +3751,7 @@
                 </a:solidFill>
                 <a:latin typeface="Segoe UI"/>
               </a:rPr>
-              <a:t>إخفاء الشبكة — اتصال خفي</a:t>
+              <a:t>إخفاء الفيديو — VideoHide</a:t>
             </a:r>
           </a:p>
           <a:p>
@@ -3727,7 +3767,7 @@
                 </a:solidFill>
                 <a:latin typeface="Segoe UI"/>
               </a:rPr>
-              <a:t>Network Hiding — Covert Communication</a:t>
+              <a:t>Video Hiding</a:t>
             </a:r>
           </a:p>
         </p:txBody>
@@ -3779,7 +3819,7 @@
                   <a:srgbClr val="08130D"/>
                 </a:solidFill>
               </a:rPr>
-              <a:t>08</a:t>
+              <a:t>07</a:t>
             </a:r>
           </a:p>
         </p:txBody>
@@ -3836,8 +3876,8 @@
         </p:nvSpPr>
         <p:spPr>
           <a:xfrm>
-            <a:off x="731520" y="1371600"/>
-            <a:ext cx="10698480" cy="822960"/>
+            <a:off x="731520" y="1417320"/>
+            <a:ext cx="10698480" cy="1920240"/>
           </a:xfrm>
           <a:prstGeom prst="rect">
             <a:avLst/>
@@ -3852,140 +3892,109 @@
           <a:p>
             <a:pPr algn="l">
               <a:spcAft>
-                <a:spcPts val="600"/>
-              </a:spcAft>
-            </a:pPr>
-            <a:r>
-              <a:rPr sz="1400" b="1">
+                <a:spcPts val="1000"/>
+              </a:spcAft>
+            </a:pPr>
+            <a:r>
+              <a:rPr sz="1500" b="0">
                 <a:solidFill>
                   <a:srgbClr val="E6E6E6"/>
                 </a:solidFill>
                 <a:latin typeface="Segoe UI"/>
               </a:rPr>
-              <a:t>Sender  :  Secret Data → Hide/Encode into Network Traffic → Transmit</a:t>
-            </a:r>
-          </a:p>
-          <a:p>
-            <a:pPr algn="l">
-              <a:spcAft>
-                <a:spcPts val="600"/>
-              </a:spcAft>
-            </a:pPr>
-            <a:r>
-              <a:rPr sz="1400" b="1">
+              <a:t>• لا يعتمد على برنامج جاهز واحد: VideoHide module + سكريبت videohide.sh + FFmpeg + FFprobe</a:t>
+            </a:r>
+          </a:p>
+          <a:p>
+            <a:pPr algn="l">
+              <a:spcAft>
+                <a:spcPts val="1000"/>
+              </a:spcAft>
+            </a:pPr>
+            <a:r>
+              <a:rPr sz="1500" b="0">
                 <a:solidFill>
                   <a:srgbClr val="E6E6E6"/>
                 </a:solidFill>
                 <a:latin typeface="Segoe UI"/>
               </a:rPr>
-              <a:t>Receiver:  Receive Traffic → Read/Detect Hidden Data → Extract/Reassemble Original Data</a:t>
-            </a:r>
-          </a:p>
-        </p:txBody>
-      </p:sp>
-      <p:sp>
-        <p:nvSpPr>
-          <p:cNvPr id="7" name="TextBox 6"/>
-          <p:cNvSpPr txBox="1"/>
-          <p:nvPr/>
-        </p:nvSpPr>
-        <p:spPr>
-          <a:xfrm>
-            <a:off x="731520" y="2"/>
-            <a:ext cx="10698480" cy="1920240"/>
+              <a:t>• Video LSB  — تعديل LSB في المسار الصوتي للفيديو مع نسخ الإطارات البصرية كما هي (-c:v copy) → صفر تغيير بصري</a:t>
+            </a:r>
+          </a:p>
+          <a:p>
+            <a:pPr algn="l">
+              <a:spcAft>
+                <a:spcPts val="1000"/>
+              </a:spcAft>
+            </a:pPr>
+            <a:r>
+              <a:rPr sz="1500" b="0">
+                <a:solidFill>
+                  <a:srgbClr val="E6E6E6"/>
+                </a:solidFill>
+                <a:latin typeface="Segoe UI"/>
+              </a:rPr>
+              <a:t>• Container / File Hiding  — استغلال ملف الفيديو لإخفاء بيانات إضافية (حمولة مشفّرة + تذييل موقّع)</a:t>
+            </a:r>
+          </a:p>
+          <a:p>
+            <a:pPr algn="l">
+              <a:spcAft>
+                <a:spcPts val="1000"/>
+              </a:spcAft>
+            </a:pPr>
+            <a:r>
+              <a:rPr sz="1500" b="0">
+                <a:solidFill>
+                  <a:srgbClr val="E6E6E6"/>
+                </a:solidFill>
+                <a:latin typeface="Segoe UI"/>
+              </a:rPr>
+              <a:t>• Spread Spectrum  — نشر البيانات داخل معلومات الفيديو (DSSS على المسار الصوتي)</a:t>
+            </a:r>
+          </a:p>
+          <a:p>
+            <a:pPr algn="l">
+              <a:spcAft>
+                <a:spcPts val="1000"/>
+              </a:spcAft>
+            </a:pPr>
+            <a:r>
+              <a:rPr sz="1500" b="0">
+                <a:solidFill>
+                  <a:srgbClr val="E6E6E6"/>
+                </a:solidFill>
+                <a:latin typeface="Segoe UI"/>
+              </a:rPr>
+              <a:t>• التحليل: ffprobe يعرض الـ Streams (codec / bitrate / duration), FFmpeg يستخرج ويعيد ترميز الصوت</a:t>
+            </a:r>
+          </a:p>
+        </p:txBody>
+      </p:sp>
+      <p:pic>
+        <p:nvPicPr>
+          <p:cNvPr id="7" name="Picture 6" descr="07_video_hiding.png"/>
+          <p:cNvPicPr>
+            <a:picLocks noChangeAspect="1"/>
+          </p:cNvPicPr>
+          <p:nvPr/>
+        </p:nvPicPr>
+        <p:blipFill>
+          <a:blip r:embed="rId2"/>
+          <a:stretch>
+            <a:fillRect/>
+          </a:stretch>
+        </p:blipFill>
+        <p:spPr>
+          <a:xfrm>
+            <a:off x="731520" y="4297680"/>
+            <a:ext cx="5303520" cy="3305092"/>
           </a:xfrm>
           <a:prstGeom prst="rect">
             <a:avLst/>
           </a:prstGeom>
-          <a:noFill/>
-        </p:spPr>
-        <p:txBody>
-          <a:bodyPr wrap="square" anchor="t">
-            <a:spAutoFit/>
-          </a:bodyPr>
-          <a:lstStyle/>
-          <a:p>
-            <a:pPr algn="l">
-              <a:spcAft>
-                <a:spcPts val="800"/>
-              </a:spcAft>
-            </a:pPr>
-            <a:r>
-              <a:rPr sz="1400" b="0">
-                <a:solidFill>
-                  <a:srgbClr val="E6E6E6"/>
-                </a:solidFill>
-                <a:latin typeface="Segoe UI"/>
-              </a:rPr>
-              <a:t>• IPv4 Identification (IP ID) LSB — بت في حقل معرف الحزمة</a:t>
-            </a:r>
-          </a:p>
-          <a:p>
-            <a:pPr algn="l">
-              <a:spcAft>
-                <a:spcPts val="800"/>
-              </a:spcAft>
-            </a:pPr>
-            <a:r>
-              <a:rPr sz="1400" b="0">
-                <a:solidFill>
-                  <a:srgbClr val="E6E6E6"/>
-                </a:solidFill>
-                <a:latin typeface="Segoe UI"/>
-              </a:rPr>
-              <a:t>• TCP Initial Sequence Number (ISN) LSB — بت في الرقم التسلسلي الأول</a:t>
-            </a:r>
-          </a:p>
-          <a:p>
-            <a:pPr algn="l">
-              <a:spcAft>
-                <a:spcPts val="800"/>
-              </a:spcAft>
-            </a:pPr>
-            <a:r>
-              <a:rPr sz="1400" b="0">
-                <a:solidFill>
-                  <a:srgbClr val="E6E6E6"/>
-                </a:solidFill>
-                <a:latin typeface="Segoe UI"/>
-              </a:rPr>
-              <a:t>• Covert Timing Channel — بت في التأخير بين الحزم</a:t>
-            </a:r>
-          </a:p>
-          <a:p>
-            <a:pPr algn="l">
-              <a:spcAft>
-                <a:spcPts val="800"/>
-              </a:spcAft>
-            </a:pPr>
-            <a:r>
-              <a:rPr sz="1400" b="0">
-                <a:solidFill>
-                  <a:srgbClr val="E6E6E6"/>
-                </a:solidFill>
-                <a:latin typeface="Segoe UI"/>
-              </a:rPr>
-              <a:t>• بناء حزم Ethernet/IPv4/TCP يدوياً بـ Python (مكتبة pcap خاصة) + إمكانية البث الحي (scapy)</a:t>
-            </a:r>
-          </a:p>
-          <a:p>
-            <a:pPr algn="l">
-              <a:spcAft>
-                <a:spcPts val="800"/>
-              </a:spcAft>
-            </a:pPr>
-            <a:r>
-              <a:rPr sz="1400" b="0">
-                <a:solidFill>
-                  <a:srgbClr val="E6E6E6"/>
-                </a:solidFill>
-                <a:latin typeface="Segoe UI"/>
-              </a:rPr>
-              <a:t>• كشف تلقائي للقناة الخفية: نمط LSB متوازن غير متناوب / تأخيرات ثنائية النمط</a:t>
-            </a:r>
-          </a:p>
-        </p:txBody>
-      </p:sp>
+        </p:spPr>
+      </p:pic>
     </p:spTree>
   </p:cSld>
   <p:clrMapOvr>
@@ -4082,7 +4091,7 @@
                 </a:solidFill>
                 <a:latin typeface="Segoe UI"/>
               </a:rPr>
-              <a:t>البرامج الضارة والإخفاء والتهرب</a:t>
+              <a:t>إخفاء الشبكة — اتصال خفي</a:t>
             </a:r>
           </a:p>
           <a:p>
@@ -4098,7 +4107,7 @@
                 </a:solidFill>
                 <a:latin typeface="Segoe UI"/>
               </a:rPr>
-              <a:t>Malware Hiding &amp; Evasion</a:t>
+              <a:t>Network Hiding — Covert Communication</a:t>
             </a:r>
           </a:p>
         </p:txBody>
@@ -4150,7 +4159,7 @@
                   <a:srgbClr val="08130D"/>
                 </a:solidFill>
               </a:rPr>
-              <a:t>09</a:t>
+              <a:t>08</a:t>
             </a:r>
           </a:p>
         </p:txBody>
@@ -4207,8 +4216,8 @@
         </p:nvSpPr>
         <p:spPr>
           <a:xfrm>
-            <a:off x="731520" y="1417320"/>
-            <a:ext cx="10698480" cy="1920240"/>
+            <a:off x="731520" y="1371600"/>
+            <a:ext cx="10698480" cy="822960"/>
           </a:xfrm>
           <a:prstGeom prst="rect">
             <a:avLst/>
@@ -4223,81 +4232,136 @@
           <a:p>
             <a:pPr algn="l">
               <a:spcAft>
-                <a:spcPts val="1200"/>
-              </a:spcAft>
-            </a:pPr>
-            <a:r>
-              <a:rPr sz="1500" b="0">
+                <a:spcPts val="600"/>
+              </a:spcAft>
+            </a:pPr>
+            <a:r>
+              <a:rPr sz="1400" b="1">
                 <a:solidFill>
                   <a:srgbClr val="E6E6E6"/>
                 </a:solidFill>
                 <a:latin typeface="Segoe UI"/>
               </a:rPr>
-              <a:t>• دراسة تقنيات Malware Hiding وتحليل العينات واكتشاف مؤشرات Evasion</a:t>
-            </a:r>
-          </a:p>
-          <a:p>
-            <a:pPr algn="l">
-              <a:spcAft>
-                <a:spcPts val="1200"/>
-              </a:spcAft>
-            </a:pPr>
-            <a:r>
-              <a:rPr sz="1500" b="0">
+              <a:t>Sender  :  Secret Data → Hide/Encode into Network Traffic → Transmit</a:t>
+            </a:r>
+          </a:p>
+          <a:p>
+            <a:pPr algn="l">
+              <a:spcAft>
+                <a:spcPts val="600"/>
+              </a:spcAft>
+            </a:pPr>
+            <a:r>
+              <a:rPr sz="1400" b="1">
                 <a:solidFill>
                   <a:srgbClr val="E6E6E6"/>
                 </a:solidFill>
                 <a:latin typeface="Segoe UI"/>
               </a:rPr>
-              <a:t>• فحص Payloads / Executables (PE + ELF) وربط النتائج بـ Forensics</a:t>
-            </a:r>
-          </a:p>
-          <a:p>
-            <a:pPr algn="l">
-              <a:spcAft>
-                <a:spcPts val="1200"/>
-              </a:spcAft>
-            </a:pPr>
-            <a:r>
-              <a:rPr sz="1500" b="0">
+              <a:t>Receiver:  Receive Traffic → Read/Detect Hidden Data → Extract/Reassemble Original Data</a:t>
+            </a:r>
+          </a:p>
+        </p:txBody>
+      </p:sp>
+      <p:sp>
+        <p:nvSpPr>
+          <p:cNvPr id="7" name="TextBox 6"/>
+          <p:cNvSpPr txBox="1"/>
+          <p:nvPr/>
+        </p:nvSpPr>
+        <p:spPr>
+          <a:xfrm>
+            <a:off x="731520" y="2"/>
+            <a:ext cx="10698480" cy="1920240"/>
+          </a:xfrm>
+          <a:prstGeom prst="rect">
+            <a:avLst/>
+          </a:prstGeom>
+          <a:noFill/>
+        </p:spPr>
+        <p:txBody>
+          <a:bodyPr wrap="square" anchor="t">
+            <a:spAutoFit/>
+          </a:bodyPr>
+          <a:lstStyle/>
+          <a:p>
+            <a:pPr algn="l">
+              <a:spcAft>
+                <a:spcPts val="800"/>
+              </a:spcAft>
+            </a:pPr>
+            <a:r>
+              <a:rPr sz="1400" b="0">
                 <a:solidFill>
                   <a:srgbClr val="E6E6E6"/>
                 </a:solidFill>
                 <a:latin typeface="Segoe UI"/>
               </a:rPr>
-              <a:t>• الكشف عن مؤشرات الأدوات: PyInstaller (MEI/٬PYZ) · WinRAR (Rar!/SFX) · Sliver · Metasploit (meterpreter/msfvenom)</a:t>
-            </a:r>
-          </a:p>
-          <a:p>
-            <a:pPr algn="l">
-              <a:spcAft>
-                <a:spcPts val="1200"/>
-              </a:spcAft>
-            </a:pPr>
-            <a:r>
-              <a:rPr sz="1500" b="0">
+              <a:t>• IPv4 Identification (IP ID) LSB — بت في حقل معرف الحزمة</a:t>
+            </a:r>
+          </a:p>
+          <a:p>
+            <a:pPr algn="l">
+              <a:spcAft>
+                <a:spcPts val="800"/>
+              </a:spcAft>
+            </a:pPr>
+            <a:r>
+              <a:rPr sz="1400" b="0">
                 <a:solidFill>
                   <a:srgbClr val="E6E6E6"/>
                 </a:solidFill>
                 <a:latin typeface="Segoe UI"/>
               </a:rPr>
-              <a:t>• إنتروبيا الأقسام &gt; 7.0 → احتمال ترميز/تغليف، والـ Overlay → بيانات ملحقة</a:t>
-            </a:r>
-          </a:p>
-          <a:p>
-            <a:pPr algn="l">
-              <a:spcAft>
-                <a:spcPts val="1200"/>
-              </a:spcAft>
-            </a:pPr>
-            <a:r>
-              <a:rPr sz="1500" b="0">
+              <a:t>• TCP Initial Sequence Number (ISN) LSB — بت في الرقم التسلسلي الأول</a:t>
+            </a:r>
+          </a:p>
+          <a:p>
+            <a:pPr algn="l">
+              <a:spcAft>
+                <a:spcPts val="800"/>
+              </a:spcAft>
+            </a:pPr>
+            <a:r>
+              <a:rPr sz="1400" b="0">
                 <a:solidFill>
                   <a:srgbClr val="E6E6E6"/>
                 </a:solidFill>
                 <a:latin typeface="Segoe UI"/>
               </a:rPr>
-              <a:t>• التركيز على التحليل والكشف والفهم الأكاديمي للتقنيات (نماذج خاملة فقط — لا تُنتج أدوات ضارة)</a:t>
+              <a:t>• Covert Timing Channel — بت في التأخير بين الحزم</a:t>
+            </a:r>
+          </a:p>
+          <a:p>
+            <a:pPr algn="l">
+              <a:spcAft>
+                <a:spcPts val="800"/>
+              </a:spcAft>
+            </a:pPr>
+            <a:r>
+              <a:rPr sz="1400" b="0">
+                <a:solidFill>
+                  <a:srgbClr val="E6E6E6"/>
+                </a:solidFill>
+                <a:latin typeface="Segoe UI"/>
+              </a:rPr>
+              <a:t>• بناء حزم Ethernet/IPv4/TCP يدوياً بـ Python (مكتبة pcap خاصة) + إمكانية البث الحي (scapy)</a:t>
+            </a:r>
+          </a:p>
+          <a:p>
+            <a:pPr algn="l">
+              <a:spcAft>
+                <a:spcPts val="800"/>
+              </a:spcAft>
+            </a:pPr>
+            <a:r>
+              <a:rPr sz="1400" b="0">
+                <a:solidFill>
+                  <a:srgbClr val="E6E6E6"/>
+                </a:solidFill>
+                <a:latin typeface="Segoe UI"/>
+              </a:rPr>
+              <a:t>• كشف تلقائي للقناة الخفية: نمط LSB متوازن غير متناوب / تأخيرات ثنائية النمط</a:t>
             </a:r>
           </a:p>
         </p:txBody>
@@ -4398,7 +4462,7 @@
                 </a:solidFill>
                 <a:latin typeface="Segoe UI"/>
               </a:rPr>
-              <a:t>إدارة القضايا والتقارير</a:t>
+              <a:t>البرامج الضارة والإخفاء والتهرب</a:t>
             </a:r>
           </a:p>
           <a:p>
@@ -4414,7 +4478,7 @@
                 </a:solidFill>
                 <a:latin typeface="Segoe UI"/>
               </a:rPr>
-              <a:t>Case Management &amp; Reports</a:t>
+              <a:t>Malware Hiding &amp; Evasion</a:t>
             </a:r>
           </a:p>
         </p:txBody>
@@ -4466,7 +4530,7 @@
                   <a:srgbClr val="08130D"/>
                 </a:solidFill>
               </a:rPr>
-              <a:t>10-11</a:t>
+              <a:t>09</a:t>
             </a:r>
           </a:p>
         </p:txBody>
@@ -4524,7 +4588,7 @@
         <p:spPr>
           <a:xfrm>
             <a:off x="731520" y="1417320"/>
-            <a:ext cx="10698480" cy="1536192"/>
+            <a:ext cx="10698480" cy="1920240"/>
           </a:xfrm>
           <a:prstGeom prst="rect">
             <a:avLst/>
@@ -4543,13 +4607,13 @@
               </a:spcAft>
             </a:pPr>
             <a:r>
-              <a:rPr sz="1600" b="0">
+              <a:rPr sz="1500" b="0">
                 <a:solidFill>
                   <a:srgbClr val="E6E6E6"/>
                 </a:solidFill>
                 <a:latin typeface="Segoe UI"/>
               </a:rPr>
-              <a:t>• Cases Management  — إنشاء/فتح/إغلاق القضايا + الأدلة والنتائج المرتبطة بها</a:t>
+              <a:t>• دراسة تقنيات Malware Hiding وتحليل العينات واكتشاف مؤشرات Evasion</a:t>
             </a:r>
           </a:p>
           <a:p>
@@ -4559,13 +4623,13 @@
               </a:spcAft>
             </a:pPr>
             <a:r>
-              <a:rPr sz="1600" b="0">
+              <a:rPr sz="1500" b="0">
                 <a:solidFill>
                   <a:srgbClr val="E6E6E6"/>
                 </a:solidFill>
                 <a:latin typeface="Segoe UI"/>
               </a:rPr>
-              <a:t>• Reports Generation  — تصدير التقارير بصيغ Markdown / JSON / HTML</a:t>
+              <a:t>• فحص Payloads / Executables (PE + ELF) وربط النتائج بـ Forensics</a:t>
             </a:r>
           </a:p>
           <a:p>
@@ -4575,13 +4639,13 @@
               </a:spcAft>
             </a:pPr>
             <a:r>
-              <a:rPr sz="1600" b="0">
+              <a:rPr sz="1500" b="0">
                 <a:solidFill>
                   <a:srgbClr val="E6E6E6"/>
                 </a:solidFill>
                 <a:latin typeface="Segoe UI"/>
               </a:rPr>
-              <a:t>• Investigation Logs  — سجل تحقيقات زمني (logs/investigation.log) يسجّل كل عملية تلقائياً</a:t>
+              <a:t>• الكشف عن مؤشرات الأدوات: PyInstaller (MEI/٬PYZ) · WinRAR (Rar!/SFX) · Sliver · Metasploit (meterpreter/msfvenom)</a:t>
             </a:r>
           </a:p>
           <a:p>
@@ -4591,41 +4655,33 @@
               </a:spcAft>
             </a:pPr>
             <a:r>
-              <a:rPr sz="1600" b="0">
+              <a:rPr sz="1500" b="0">
                 <a:solidFill>
                   <a:srgbClr val="E6E6E6"/>
                 </a:solidFill>
                 <a:latin typeface="Segoe UI"/>
               </a:rPr>
-              <a:t>• كل عملية إخفاء/استخراج/فحص في الواجهة تُسجَّل في القضية النشطة تلقائياً</a:t>
-            </a:r>
-          </a:p>
-        </p:txBody>
-      </p:sp>
-      <p:pic>
-        <p:nvPicPr>
-          <p:cNvPr id="7" name="Picture 6" descr="11_case_management.png"/>
-          <p:cNvPicPr>
-            <a:picLocks noChangeAspect="1"/>
-          </p:cNvPicPr>
-          <p:nvPr/>
-        </p:nvPicPr>
-        <p:blipFill>
-          <a:blip r:embed="rId2"/>
-          <a:stretch>
-            <a:fillRect/>
-          </a:stretch>
-        </p:blipFill>
-        <p:spPr>
-          <a:xfrm>
-            <a:off x="731520" y="4114800"/>
-            <a:ext cx="5212080" cy="3248108"/>
-          </a:xfrm>
-          <a:prstGeom prst="rect">
-            <a:avLst/>
-          </a:prstGeom>
-        </p:spPr>
-      </p:pic>
+              <a:t>• إنتروبيا الأقسام &gt; 7.0 → احتمال ترميز/تغليف، والـ Overlay → بيانات ملحقة</a:t>
+            </a:r>
+          </a:p>
+          <a:p>
+            <a:pPr algn="l">
+              <a:spcAft>
+                <a:spcPts val="1200"/>
+              </a:spcAft>
+            </a:pPr>
+            <a:r>
+              <a:rPr sz="1500" b="0">
+                <a:solidFill>
+                  <a:srgbClr val="E6E6E6"/>
+                </a:solidFill>
+                <a:latin typeface="Segoe UI"/>
+              </a:rPr>
+              <a:t>• التركيز على التحليل والكشف والفهم الأكاديمي للتقنيات (نماذج خاملة فقط — لا تُنتج أدوات ضارة)</a:t>
+            </a:r>
+          </a:p>
+        </p:txBody>
+      </p:sp>
     </p:spTree>
   </p:cSld>
   <p:clrMapOvr>
@@ -4722,7 +4778,7 @@
                 </a:solidFill>
                 <a:latin typeface="Segoe UI"/>
               </a:rPr>
-              <a:t>عرض النتائج الحية</a:t>
+              <a:t>إدارة القضايا والتقارير</a:t>
             </a:r>
           </a:p>
           <a:p>
@@ -4738,7 +4794,7 @@
                 </a:solidFill>
                 <a:latin typeface="Segoe UI"/>
               </a:rPr>
-              <a:t>Live Results &amp; Screenshots</a:t>
+              <a:t>Case Management &amp; Reports</a:t>
             </a:r>
           </a:p>
         </p:txBody>
@@ -4790,7 +4846,7 @@
                   <a:srgbClr val="08130D"/>
                 </a:solidFill>
               </a:rPr>
-              <a:t>DEMO</a:t>
+              <a:t>10-11</a:t>
             </a:r>
           </a:p>
         </p:txBody>
@@ -4839,9 +4895,96 @@
           </a:p>
         </p:txBody>
       </p:sp>
+      <p:sp>
+        <p:nvSpPr>
+          <p:cNvPr id="6" name="TextBox 5"/>
+          <p:cNvSpPr txBox="1"/>
+          <p:nvPr/>
+        </p:nvSpPr>
+        <p:spPr>
+          <a:xfrm>
+            <a:off x="731520" y="1417320"/>
+            <a:ext cx="10698480" cy="1536192"/>
+          </a:xfrm>
+          <a:prstGeom prst="rect">
+            <a:avLst/>
+          </a:prstGeom>
+          <a:noFill/>
+        </p:spPr>
+        <p:txBody>
+          <a:bodyPr wrap="square" anchor="t">
+            <a:spAutoFit/>
+          </a:bodyPr>
+          <a:lstStyle/>
+          <a:p>
+            <a:pPr algn="l">
+              <a:spcAft>
+                <a:spcPts val="1200"/>
+              </a:spcAft>
+            </a:pPr>
+            <a:r>
+              <a:rPr sz="1600" b="0">
+                <a:solidFill>
+                  <a:srgbClr val="E6E6E6"/>
+                </a:solidFill>
+                <a:latin typeface="Segoe UI"/>
+              </a:rPr>
+              <a:t>• Cases Management  — إنشاء/فتح/إغلاق القضايا + الأدلة والنتائج المرتبطة بها</a:t>
+            </a:r>
+          </a:p>
+          <a:p>
+            <a:pPr algn="l">
+              <a:spcAft>
+                <a:spcPts val="1200"/>
+              </a:spcAft>
+            </a:pPr>
+            <a:r>
+              <a:rPr sz="1600" b="0">
+                <a:solidFill>
+                  <a:srgbClr val="E6E6E6"/>
+                </a:solidFill>
+                <a:latin typeface="Segoe UI"/>
+              </a:rPr>
+              <a:t>• Reports Generation  — تصدير التقارير بصيغ Markdown / JSON / HTML</a:t>
+            </a:r>
+          </a:p>
+          <a:p>
+            <a:pPr algn="l">
+              <a:spcAft>
+                <a:spcPts val="1200"/>
+              </a:spcAft>
+            </a:pPr>
+            <a:r>
+              <a:rPr sz="1600" b="0">
+                <a:solidFill>
+                  <a:srgbClr val="E6E6E6"/>
+                </a:solidFill>
+                <a:latin typeface="Segoe UI"/>
+              </a:rPr>
+              <a:t>• Investigation Logs  — سجل تحقيقات زمني (logs/investigation.log) يسجّل كل عملية تلقائياً</a:t>
+            </a:r>
+          </a:p>
+          <a:p>
+            <a:pPr algn="l">
+              <a:spcAft>
+                <a:spcPts val="1200"/>
+              </a:spcAft>
+            </a:pPr>
+            <a:r>
+              <a:rPr sz="1600" b="0">
+                <a:solidFill>
+                  <a:srgbClr val="E6E6E6"/>
+                </a:solidFill>
+                <a:latin typeface="Segoe UI"/>
+              </a:rPr>
+              <a:t>• كل عملية إخفاء/استخراج/فحص في الواجهة تُسجَّل في القضية النشطة تلقائياً</a:t>
+            </a:r>
+          </a:p>
+        </p:txBody>
+      </p:sp>
       <p:pic>
         <p:nvPicPr>
-          <p:cNvPr id="6" name="Picture 5" descr="GUISheet_dashboard.png"/>
+          <p:cNvPr id="7" name="Picture 6" descr="11_case_management.png"/>
           <p:cNvPicPr>
             <a:picLocks noChangeAspect="1"/>
           </p:cNvPicPr>
@@ -4855,77 +4998,14 @@
         </p:blipFill>
         <p:spPr>
           <a:xfrm>
-            <a:off x="502920" y="1325880"/>
-            <a:ext cx="5486400" cy="5073562"/>
+            <a:off x="731520" y="4114800"/>
+            <a:ext cx="5212080" cy="3248108"/>
           </a:xfrm>
           <a:prstGeom prst="rect">
             <a:avLst/>
           </a:prstGeom>
         </p:spPr>
       </p:pic>
-      <p:pic>
-        <p:nvPicPr>
-          <p:cNvPr id="7" name="Picture 6" descr="CLISheet_terminal.png"/>
-          <p:cNvPicPr>
-            <a:picLocks noChangeAspect="1"/>
-          </p:cNvPicPr>
-          <p:nvPr/>
-        </p:nvPicPr>
-        <p:blipFill>
-          <a:blip r:embed="rId3"/>
-          <a:stretch>
-            <a:fillRect/>
-          </a:stretch>
-        </p:blipFill>
-        <p:spPr>
-          <a:xfrm>
-            <a:off x="6172200" y="1325880"/>
-            <a:ext cx="5486400" cy="5073562"/>
-          </a:xfrm>
-          <a:prstGeom prst="rect">
-            <a:avLst/>
-          </a:prstGeom>
-        </p:spPr>
-      </p:pic>
-      <p:sp>
-        <p:nvSpPr>
-          <p:cNvPr id="8" name="TextBox 7"/>
-          <p:cNvSpPr txBox="1"/>
-          <p:nvPr/>
-        </p:nvSpPr>
-        <p:spPr>
-          <a:xfrm>
-            <a:off x="502920" y="6126480"/>
-            <a:ext cx="11155680" cy="548640"/>
-          </a:xfrm>
-          <a:prstGeom prst="rect">
-            <a:avLst/>
-          </a:prstGeom>
-          <a:noFill/>
-        </p:spPr>
-        <p:txBody>
-          <a:bodyPr wrap="square" anchor="t">
-            <a:spAutoFit/>
-          </a:bodyPr>
-          <a:lstStyle/>
-          <a:p>
-            <a:pPr algn="ctr">
-              <a:spcAft>
-                <a:spcPts val="600"/>
-              </a:spcAft>
-            </a:pPr>
-            <a:r>
-              <a:rPr sz="1400" b="1">
-                <a:solidFill>
-                  <a:srgbClr val="00D98B"/>
-                </a:solidFill>
-                <a:latin typeface="Segoe UI"/>
-              </a:rPr>
-              <a:t>GUI: 10 صفحات ·  CLI: 22 أمراً ·  أدوات كالي 8/8 مُرصودة تلقائياً</a:t>
-            </a:r>
-          </a:p>
-        </p:txBody>
-      </p:sp>
     </p:spTree>
   </p:cSld>
   <p:clrMapOvr>
@@ -5022,7 +5102,7 @@
                 </a:solidFill>
                 <a:latin typeface="Segoe UI"/>
               </a:rPr>
-              <a:t>نتائج التحقق</a:t>
+              <a:t>عرض النتائج الحية</a:t>
             </a:r>
           </a:p>
           <a:p>
@@ -5038,7 +5118,7 @@
                 </a:solidFill>
                 <a:latin typeface="Segoe UI"/>
               </a:rPr>
-              <a:t>Verification Results</a:t>
+              <a:t>Live Results &amp; Screenshots</a:t>
             </a:r>
           </a:p>
         </p:txBody>
@@ -5090,7 +5170,7 @@
                   <a:srgbClr val="08130D"/>
                 </a:solidFill>
               </a:rPr>
-              <a:t>TEST</a:t>
+              <a:t>DEMO</a:t>
             </a:r>
           </a:p>
         </p:txBody>
@@ -5139,327 +5219,89 @@
           </a:p>
         </p:txBody>
       </p:sp>
-      <p:sp>
-        <p:nvSpPr>
-          <p:cNvPr id="6" name="Rounded Rectangle 5"/>
-          <p:cNvSpPr/>
-          <p:nvPr/>
-        </p:nvSpPr>
-        <p:spPr>
-          <a:xfrm>
-            <a:off x="822960" y="1645920"/>
-            <a:ext cx="10515600" cy="685800"/>
-          </a:xfrm>
-          <a:prstGeom prst="roundRect">
-            <a:avLst/>
-          </a:prstGeom>
-          <a:solidFill>
-            <a:srgbClr val="161B22"/>
-          </a:solidFill>
-          <a:ln>
-            <a:solidFill>
-              <a:srgbClr val="00D98B"/>
-            </a:solidFill>
-          </a:ln>
-          <a:effectLst/>
-        </p:spPr>
-        <p:style>
-          <a:lnRef idx="1">
-            <a:schemeClr val="accent1"/>
-          </a:lnRef>
-          <a:fillRef idx="3">
-            <a:schemeClr val="accent1"/>
-          </a:fillRef>
-          <a:effectRef idx="2">
-            <a:schemeClr val="accent1"/>
-          </a:effectRef>
-          <a:fontRef idx="minor">
-            <a:schemeClr val="lt1"/>
-          </a:fontRef>
-        </p:style>
-        <p:txBody>
-          <a:bodyPr rtlCol="0" anchor="ctr" wrap="square"/>
-          <a:lstStyle/>
-          <a:p>
-            <a:pPr algn="ctr"/>
-            <a:r>
-              <a:rPr sz="1500">
-                <a:solidFill>
-                  <a:srgbClr val="E6E6E6"/>
-                </a:solidFill>
-              </a:rPr>
-              <a:t>اختبارات التكامل (كل وحدة دالة)</a:t>
-            </a:r>
-          </a:p>
-          <a:p>
-            <a:pPr algn="r"/>
-            <a:r>
-              <a:rPr sz="1500" b="1">
+      <p:pic>
+        <p:nvPicPr>
+          <p:cNvPr id="6" name="Picture 5" descr="GUISheet_dashboard.png"/>
+          <p:cNvPicPr>
+            <a:picLocks noChangeAspect="1"/>
+          </p:cNvPicPr>
+          <p:nvPr/>
+        </p:nvPicPr>
+        <p:blipFill>
+          <a:blip r:embed="rId2"/>
+          <a:stretch>
+            <a:fillRect/>
+          </a:stretch>
+        </p:blipFill>
+        <p:spPr>
+          <a:xfrm>
+            <a:off x="502920" y="1325880"/>
+            <a:ext cx="5486400" cy="5073562"/>
+          </a:xfrm>
+          <a:prstGeom prst="rect">
+            <a:avLst/>
+          </a:prstGeom>
+        </p:spPr>
+      </p:pic>
+      <p:pic>
+        <p:nvPicPr>
+          <p:cNvPr id="7" name="Picture 6" descr="CLISheet_terminal.png"/>
+          <p:cNvPicPr>
+            <a:picLocks noChangeAspect="1"/>
+          </p:cNvPicPr>
+          <p:nvPr/>
+        </p:nvPicPr>
+        <p:blipFill>
+          <a:blip r:embed="rId3"/>
+          <a:stretch>
+            <a:fillRect/>
+          </a:stretch>
+        </p:blipFill>
+        <p:spPr>
+          <a:xfrm>
+            <a:off x="6172200" y="1325880"/>
+            <a:ext cx="5486400" cy="5073562"/>
+          </a:xfrm>
+          <a:prstGeom prst="rect">
+            <a:avLst/>
+          </a:prstGeom>
+        </p:spPr>
+      </p:pic>
+      <p:sp>
+        <p:nvSpPr>
+          <p:cNvPr id="8" name="TextBox 7"/>
+          <p:cNvSpPr txBox="1"/>
+          <p:nvPr/>
+        </p:nvSpPr>
+        <p:spPr>
+          <a:xfrm>
+            <a:off x="502920" y="6126480"/>
+            <a:ext cx="11155680" cy="548640"/>
+          </a:xfrm>
+          <a:prstGeom prst="rect">
+            <a:avLst/>
+          </a:prstGeom>
+          <a:noFill/>
+        </p:spPr>
+        <p:txBody>
+          <a:bodyPr wrap="square" anchor="t">
+            <a:spAutoFit/>
+          </a:bodyPr>
+          <a:lstStyle/>
+          <a:p>
+            <a:pPr algn="ctr">
+              <a:spcAft>
+                <a:spcPts val="600"/>
+              </a:spcAft>
+            </a:pPr>
+            <a:r>
+              <a:rPr sz="1400" b="1">
                 <a:solidFill>
                   <a:srgbClr val="00D98B"/>
                 </a:solidFill>
-              </a:rPr>
-              <a:t>23 / 23  ✓</a:t>
-            </a:r>
-          </a:p>
-        </p:txBody>
-      </p:sp>
-      <p:sp>
-        <p:nvSpPr>
-          <p:cNvPr id="7" name="Rounded Rectangle 6"/>
-          <p:cNvSpPr/>
-          <p:nvPr/>
-        </p:nvSpPr>
-        <p:spPr>
-          <a:xfrm>
-            <a:off x="822960" y="2487168"/>
-            <a:ext cx="10515600" cy="685800"/>
-          </a:xfrm>
-          <a:prstGeom prst="roundRect">
-            <a:avLst/>
-          </a:prstGeom>
-          <a:solidFill>
-            <a:srgbClr val="161B22"/>
-          </a:solidFill>
-          <a:ln>
-            <a:solidFill>
-              <a:srgbClr val="00D98B"/>
-            </a:solidFill>
-          </a:ln>
-          <a:effectLst/>
-        </p:spPr>
-        <p:style>
-          <a:lnRef idx="1">
-            <a:schemeClr val="accent1"/>
-          </a:lnRef>
-          <a:fillRef idx="3">
-            <a:schemeClr val="accent1"/>
-          </a:fillRef>
-          <a:effectRef idx="2">
-            <a:schemeClr val="accent1"/>
-          </a:effectRef>
-          <a:fontRef idx="minor">
-            <a:schemeClr val="lt1"/>
-          </a:fontRef>
-        </p:style>
-        <p:txBody>
-          <a:bodyPr rtlCol="0" anchor="ctr" wrap="square"/>
-          <a:lstStyle/>
-          <a:p>
-            <a:pPr algn="ctr"/>
-            <a:r>
-              <a:rPr sz="1500">
-                <a:solidFill>
-                  <a:srgbClr val="E6E6E6"/>
-                </a:solidFill>
-              </a:rPr>
-              <a:t>مصفوفة المتطلبات (كل بند بفحص حي)</a:t>
-            </a:r>
-          </a:p>
-          <a:p>
-            <a:pPr algn="r"/>
-            <a:r>
-              <a:rPr sz="1500" b="1">
-                <a:solidFill>
-                  <a:srgbClr val="00D98B"/>
-                </a:solidFill>
-              </a:rPr>
-              <a:t>59 / 59  ✓</a:t>
-            </a:r>
-          </a:p>
-        </p:txBody>
-      </p:sp>
-      <p:sp>
-        <p:nvSpPr>
-          <p:cNvPr id="8" name="Rounded Rectangle 7"/>
-          <p:cNvSpPr/>
-          <p:nvPr/>
-        </p:nvSpPr>
-        <p:spPr>
-          <a:xfrm>
-            <a:off x="822960" y="3328416"/>
-            <a:ext cx="10515600" cy="685800"/>
-          </a:xfrm>
-          <a:prstGeom prst="roundRect">
-            <a:avLst/>
-          </a:prstGeom>
-          <a:solidFill>
-            <a:srgbClr val="161B22"/>
-          </a:solidFill>
-          <a:ln>
-            <a:solidFill>
-              <a:srgbClr val="00D98B"/>
-            </a:solidFill>
-          </a:ln>
-          <a:effectLst/>
-        </p:spPr>
-        <p:style>
-          <a:lnRef idx="1">
-            <a:schemeClr val="accent1"/>
-          </a:lnRef>
-          <a:fillRef idx="3">
-            <a:schemeClr val="accent1"/>
-          </a:fillRef>
-          <a:effectRef idx="2">
-            <a:schemeClr val="accent1"/>
-          </a:effectRef>
-          <a:fontRef idx="minor">
-            <a:schemeClr val="lt1"/>
-          </a:fontRef>
-        </p:style>
-        <p:txBody>
-          <a:bodyPr rtlCol="0" anchor="ctr" wrap="square"/>
-          <a:lstStyle/>
-          <a:p>
-            <a:pPr algn="ctr"/>
-            <a:r>
-              <a:rPr sz="1500">
-                <a:solidFill>
-                  <a:srgbClr val="E6E6E6"/>
-                </a:solidFill>
-              </a:rPr>
-              <a:t>أدوات Kali الحقيقية المثبتة (steghide, exiftool, binwalk, foremost, zsteg, ffmpeg…) </a:t>
-            </a:r>
-          </a:p>
-          <a:p>
-            <a:pPr algn="r"/>
-            <a:r>
-              <a:rPr sz="1500" b="1">
-                <a:solidFill>
-                  <a:srgbClr val="00D98B"/>
-                </a:solidFill>
-              </a:rPr>
-              <a:t>8 / 8  ✓</a:t>
-            </a:r>
-          </a:p>
-        </p:txBody>
-      </p:sp>
-      <p:sp>
-        <p:nvSpPr>
-          <p:cNvPr id="9" name="Rounded Rectangle 8"/>
-          <p:cNvSpPr/>
-          <p:nvPr/>
-        </p:nvSpPr>
-        <p:spPr>
-          <a:xfrm>
-            <a:off x="822960" y="4169664"/>
-            <a:ext cx="10515600" cy="685800"/>
-          </a:xfrm>
-          <a:prstGeom prst="roundRect">
-            <a:avLst/>
-          </a:prstGeom>
-          <a:solidFill>
-            <a:srgbClr val="161B22"/>
-          </a:solidFill>
-          <a:ln>
-            <a:solidFill>
-              <a:srgbClr val="00D98B"/>
-            </a:solidFill>
-          </a:ln>
-          <a:effectLst/>
-        </p:spPr>
-        <p:style>
-          <a:lnRef idx="1">
-            <a:schemeClr val="accent1"/>
-          </a:lnRef>
-          <a:fillRef idx="3">
-            <a:schemeClr val="accent1"/>
-          </a:fillRef>
-          <a:effectRef idx="2">
-            <a:schemeClr val="accent1"/>
-          </a:effectRef>
-          <a:fontRef idx="minor">
-            <a:schemeClr val="lt1"/>
-          </a:fontRef>
-        </p:style>
-        <p:txBody>
-          <a:bodyPr rtlCol="0" anchor="ctr" wrap="square"/>
-          <a:lstStyle/>
-          <a:p>
-            <a:pPr algn="ctr"/>
-            <a:r>
-              <a:rPr sz="1500">
-                <a:solidFill>
-                  <a:srgbClr val="E6E6E6"/>
-                </a:solidFill>
-              </a:rPr>
-              <a:t>جولات إخفاء/استخراج كاملة (نص·صورة·صوت×4·فيديو×3·شبكة×3)</a:t>
-            </a:r>
-          </a:p>
-          <a:p>
-            <a:pPr algn="r"/>
-            <a:r>
-              <a:rPr sz="1500" b="1">
-                <a:solidFill>
-                  <a:srgbClr val="00D98B"/>
-                </a:solidFill>
-              </a:rPr>
-              <a:t>كلها ✓</a:t>
-            </a:r>
-          </a:p>
-        </p:txBody>
-      </p:sp>
-      <p:sp>
-        <p:nvSpPr>
-          <p:cNvPr id="10" name="Rounded Rectangle 9"/>
-          <p:cNvSpPr/>
-          <p:nvPr/>
-        </p:nvSpPr>
-        <p:spPr>
-          <a:xfrm>
-            <a:off x="822960" y="5010912"/>
-            <a:ext cx="10515600" cy="685800"/>
-          </a:xfrm>
-          <a:prstGeom prst="roundRect">
-            <a:avLst/>
-          </a:prstGeom>
-          <a:solidFill>
-            <a:srgbClr val="161B22"/>
-          </a:solidFill>
-          <a:ln>
-            <a:solidFill>
-              <a:srgbClr val="FFD166"/>
-            </a:solidFill>
-          </a:ln>
-          <a:effectLst/>
-        </p:spPr>
-        <p:style>
-          <a:lnRef idx="1">
-            <a:schemeClr val="accent1"/>
-          </a:lnRef>
-          <a:fillRef idx="3">
-            <a:schemeClr val="accent1"/>
-          </a:fillRef>
-          <a:effectRef idx="2">
-            <a:schemeClr val="accent1"/>
-          </a:effectRef>
-          <a:fontRef idx="minor">
-            <a:schemeClr val="lt1"/>
-          </a:fontRef>
-        </p:style>
-        <p:txBody>
-          <a:bodyPr rtlCol="0" anchor="ctr" wrap="square"/>
-          <a:lstStyle/>
-          <a:p>
-            <a:pPr algn="ctr"/>
-            <a:r>
-              <a:rPr sz="1500">
-                <a:solidFill>
-                  <a:srgbClr val="E6E6E6"/>
-                </a:solidFill>
-              </a:rPr>
-              <a:t>مطابقة ملف المتطلبات PDF (12 قسماً)</a:t>
-            </a:r>
-          </a:p>
-          <a:p>
-            <a:pPr algn="r"/>
-            <a:r>
-              <a:rPr sz="1500" b="1">
-                <a:solidFill>
-                  <a:srgbClr val="FFD166"/>
-                </a:solidFill>
-              </a:rPr>
-              <a:t>≈ 99.8 %</a:t>
+                <a:latin typeface="Segoe UI"/>
+              </a:rPr>
+              <a:t>GUI: 10 صفحات ·  CLI: 22 أمراً ·  أدوات كالي 8/8 مُرصودة تلقائياً</a:t>
             </a:r>
           </a:p>
         </p:txBody>
@@ -5560,6 +5402,544 @@
                 </a:solidFill>
                 <a:latin typeface="Segoe UI"/>
               </a:rPr>
+              <a:t>نتائج التحقق</a:t>
+            </a:r>
+          </a:p>
+          <a:p>
+            <a:pPr algn="l">
+              <a:spcAft>
+                <a:spcPts val="600"/>
+              </a:spcAft>
+            </a:pPr>
+            <a:r>
+              <a:rPr sz="1300" b="0">
+                <a:solidFill>
+                  <a:srgbClr val="9AA4B5"/>
+                </a:solidFill>
+                <a:latin typeface="Segoe UI"/>
+              </a:rPr>
+              <a:t>Verification Results</a:t>
+            </a:r>
+          </a:p>
+        </p:txBody>
+      </p:sp>
+      <p:sp>
+        <p:nvSpPr>
+          <p:cNvPr id="4" name="Rounded Rectangle 3"/>
+          <p:cNvSpPr/>
+          <p:nvPr/>
+        </p:nvSpPr>
+        <p:spPr>
+          <a:xfrm>
+            <a:off x="10881360" y="320040"/>
+            <a:ext cx="777240" cy="411480"/>
+          </a:xfrm>
+          <a:prstGeom prst="roundRect">
+            <a:avLst/>
+          </a:prstGeom>
+          <a:solidFill>
+            <a:srgbClr val="00D98B"/>
+          </a:solidFill>
+          <a:ln>
+            <a:noFill/>
+          </a:ln>
+          <a:effectLst/>
+        </p:spPr>
+        <p:style>
+          <a:lnRef idx="1">
+            <a:schemeClr val="accent1"/>
+          </a:lnRef>
+          <a:fillRef idx="3">
+            <a:schemeClr val="accent1"/>
+          </a:fillRef>
+          <a:effectRef idx="2">
+            <a:schemeClr val="accent1"/>
+          </a:effectRef>
+          <a:fontRef idx="minor">
+            <a:schemeClr val="lt1"/>
+          </a:fontRef>
+        </p:style>
+        <p:txBody>
+          <a:bodyPr rtlCol="0" anchor="ctr"/>
+          <a:lstStyle/>
+          <a:p>
+            <a:pPr algn="ctr"/>
+            <a:r>
+              <a:rPr sz="1600" b="1">
+                <a:solidFill>
+                  <a:srgbClr val="08130D"/>
+                </a:solidFill>
+              </a:rPr>
+              <a:t>TEST</a:t>
+            </a:r>
+          </a:p>
+        </p:txBody>
+      </p:sp>
+      <p:sp>
+        <p:nvSpPr>
+          <p:cNvPr id="5" name="Rectangle 4"/>
+          <p:cNvSpPr/>
+          <p:nvPr/>
+        </p:nvSpPr>
+        <p:spPr>
+          <a:xfrm>
+            <a:off x="548640" y="1078992"/>
+            <a:ext cx="11064240" cy="27940"/>
+          </a:xfrm>
+          <a:prstGeom prst="rect">
+            <a:avLst/>
+          </a:prstGeom>
+          <a:solidFill>
+            <a:srgbClr val="00D98B"/>
+          </a:solidFill>
+          <a:ln>
+            <a:noFill/>
+          </a:ln>
+          <a:effectLst/>
+        </p:spPr>
+        <p:style>
+          <a:lnRef idx="1">
+            <a:schemeClr val="accent1"/>
+          </a:lnRef>
+          <a:fillRef idx="3">
+            <a:schemeClr val="accent1"/>
+          </a:fillRef>
+          <a:effectRef idx="2">
+            <a:schemeClr val="accent1"/>
+          </a:effectRef>
+          <a:fontRef idx="minor">
+            <a:schemeClr val="lt1"/>
+          </a:fontRef>
+        </p:style>
+        <p:txBody>
+          <a:bodyPr rtlCol="0" anchor="ctr"/>
+          <a:lstStyle/>
+          <a:p>
+            <a:pPr algn="ctr"/>
+          </a:p>
+        </p:txBody>
+      </p:sp>
+      <p:sp>
+        <p:nvSpPr>
+          <p:cNvPr id="6" name="Rounded Rectangle 5"/>
+          <p:cNvSpPr/>
+          <p:nvPr/>
+        </p:nvSpPr>
+        <p:spPr>
+          <a:xfrm>
+            <a:off x="822960" y="1645920"/>
+            <a:ext cx="10515600" cy="685800"/>
+          </a:xfrm>
+          <a:prstGeom prst="roundRect">
+            <a:avLst/>
+          </a:prstGeom>
+          <a:solidFill>
+            <a:srgbClr val="161B22"/>
+          </a:solidFill>
+          <a:ln>
+            <a:solidFill>
+              <a:srgbClr val="00D98B"/>
+            </a:solidFill>
+          </a:ln>
+          <a:effectLst/>
+        </p:spPr>
+        <p:style>
+          <a:lnRef idx="1">
+            <a:schemeClr val="accent1"/>
+          </a:lnRef>
+          <a:fillRef idx="3">
+            <a:schemeClr val="accent1"/>
+          </a:fillRef>
+          <a:effectRef idx="2">
+            <a:schemeClr val="accent1"/>
+          </a:effectRef>
+          <a:fontRef idx="minor">
+            <a:schemeClr val="lt1"/>
+          </a:fontRef>
+        </p:style>
+        <p:txBody>
+          <a:bodyPr rtlCol="0" anchor="ctr" wrap="square"/>
+          <a:lstStyle/>
+          <a:p>
+            <a:pPr algn="ctr"/>
+            <a:r>
+              <a:rPr sz="1500">
+                <a:solidFill>
+                  <a:srgbClr val="E6E6E6"/>
+                </a:solidFill>
+              </a:rPr>
+              <a:t>اختبارات التكامل (كل وحدة دالة)</a:t>
+            </a:r>
+          </a:p>
+          <a:p>
+            <a:pPr algn="r"/>
+            <a:r>
+              <a:rPr sz="1500" b="1">
+                <a:solidFill>
+                  <a:srgbClr val="00D98B"/>
+                </a:solidFill>
+              </a:rPr>
+              <a:t>24 / 24  ✓</a:t>
+            </a:r>
+          </a:p>
+        </p:txBody>
+      </p:sp>
+      <p:sp>
+        <p:nvSpPr>
+          <p:cNvPr id="7" name="Rounded Rectangle 6"/>
+          <p:cNvSpPr/>
+          <p:nvPr/>
+        </p:nvSpPr>
+        <p:spPr>
+          <a:xfrm>
+            <a:off x="822960" y="2487168"/>
+            <a:ext cx="10515600" cy="685800"/>
+          </a:xfrm>
+          <a:prstGeom prst="roundRect">
+            <a:avLst/>
+          </a:prstGeom>
+          <a:solidFill>
+            <a:srgbClr val="161B22"/>
+          </a:solidFill>
+          <a:ln>
+            <a:solidFill>
+              <a:srgbClr val="00D98B"/>
+            </a:solidFill>
+          </a:ln>
+          <a:effectLst/>
+        </p:spPr>
+        <p:style>
+          <a:lnRef idx="1">
+            <a:schemeClr val="accent1"/>
+          </a:lnRef>
+          <a:fillRef idx="3">
+            <a:schemeClr val="accent1"/>
+          </a:fillRef>
+          <a:effectRef idx="2">
+            <a:schemeClr val="accent1"/>
+          </a:effectRef>
+          <a:fontRef idx="minor">
+            <a:schemeClr val="lt1"/>
+          </a:fontRef>
+        </p:style>
+        <p:txBody>
+          <a:bodyPr rtlCol="0" anchor="ctr" wrap="square"/>
+          <a:lstStyle/>
+          <a:p>
+            <a:pPr algn="ctr"/>
+            <a:r>
+              <a:rPr sz="1500">
+                <a:solidFill>
+                  <a:srgbClr val="E6E6E6"/>
+                </a:solidFill>
+              </a:rPr>
+              <a:t>مصفوفة المتطلبات (كل بند بفحص حي)</a:t>
+            </a:r>
+          </a:p>
+          <a:p>
+            <a:pPr algn="r"/>
+            <a:r>
+              <a:rPr sz="1500" b="1">
+                <a:solidFill>
+                  <a:srgbClr val="00D98B"/>
+                </a:solidFill>
+              </a:rPr>
+              <a:t>60 / 60  ✓</a:t>
+            </a:r>
+          </a:p>
+        </p:txBody>
+      </p:sp>
+      <p:sp>
+        <p:nvSpPr>
+          <p:cNvPr id="8" name="Rounded Rectangle 7"/>
+          <p:cNvSpPr/>
+          <p:nvPr/>
+        </p:nvSpPr>
+        <p:spPr>
+          <a:xfrm>
+            <a:off x="822960" y="3328416"/>
+            <a:ext cx="10515600" cy="685800"/>
+          </a:xfrm>
+          <a:prstGeom prst="roundRect">
+            <a:avLst/>
+          </a:prstGeom>
+          <a:solidFill>
+            <a:srgbClr val="161B22"/>
+          </a:solidFill>
+          <a:ln>
+            <a:solidFill>
+              <a:srgbClr val="00D98B"/>
+            </a:solidFill>
+          </a:ln>
+          <a:effectLst/>
+        </p:spPr>
+        <p:style>
+          <a:lnRef idx="1">
+            <a:schemeClr val="accent1"/>
+          </a:lnRef>
+          <a:fillRef idx="3">
+            <a:schemeClr val="accent1"/>
+          </a:fillRef>
+          <a:effectRef idx="2">
+            <a:schemeClr val="accent1"/>
+          </a:effectRef>
+          <a:fontRef idx="minor">
+            <a:schemeClr val="lt1"/>
+          </a:fontRef>
+        </p:style>
+        <p:txBody>
+          <a:bodyPr rtlCol="0" anchor="ctr" wrap="square"/>
+          <a:lstStyle/>
+          <a:p>
+            <a:pPr algn="ctr"/>
+            <a:r>
+              <a:rPr sz="1500">
+                <a:solidFill>
+                  <a:srgbClr val="E6E6E6"/>
+                </a:solidFill>
+              </a:rPr>
+              <a:t>أدوات Kali الحقيقية المثبتة (steghide, exiftool, binwalk, foremost, zsteg, ffmpeg…) </a:t>
+            </a:r>
+          </a:p>
+          <a:p>
+            <a:pPr algn="r"/>
+            <a:r>
+              <a:rPr sz="1500" b="1">
+                <a:solidFill>
+                  <a:srgbClr val="00D98B"/>
+                </a:solidFill>
+              </a:rPr>
+              <a:t>8 / 8  ✓</a:t>
+            </a:r>
+          </a:p>
+        </p:txBody>
+      </p:sp>
+      <p:sp>
+        <p:nvSpPr>
+          <p:cNvPr id="9" name="Rounded Rectangle 8"/>
+          <p:cNvSpPr/>
+          <p:nvPr/>
+        </p:nvSpPr>
+        <p:spPr>
+          <a:xfrm>
+            <a:off x="822960" y="4169664"/>
+            <a:ext cx="10515600" cy="685800"/>
+          </a:xfrm>
+          <a:prstGeom prst="roundRect">
+            <a:avLst/>
+          </a:prstGeom>
+          <a:solidFill>
+            <a:srgbClr val="161B22"/>
+          </a:solidFill>
+          <a:ln>
+            <a:solidFill>
+              <a:srgbClr val="00D98B"/>
+            </a:solidFill>
+          </a:ln>
+          <a:effectLst/>
+        </p:spPr>
+        <p:style>
+          <a:lnRef idx="1">
+            <a:schemeClr val="accent1"/>
+          </a:lnRef>
+          <a:fillRef idx="3">
+            <a:schemeClr val="accent1"/>
+          </a:fillRef>
+          <a:effectRef idx="2">
+            <a:schemeClr val="accent1"/>
+          </a:effectRef>
+          <a:fontRef idx="minor">
+            <a:schemeClr val="lt1"/>
+          </a:fontRef>
+        </p:style>
+        <p:txBody>
+          <a:bodyPr rtlCol="0" anchor="ctr" wrap="square"/>
+          <a:lstStyle/>
+          <a:p>
+            <a:pPr algn="ctr"/>
+            <a:r>
+              <a:rPr sz="1500">
+                <a:solidFill>
+                  <a:srgbClr val="E6E6E6"/>
+                </a:solidFill>
+              </a:rPr>
+              <a:t>جولات إخفاء/استخراج كاملة (نص·صورة·صوت×4·فيديو×3·شبكة×3)</a:t>
+            </a:r>
+          </a:p>
+          <a:p>
+            <a:pPr algn="r"/>
+            <a:r>
+              <a:rPr sz="1500" b="1">
+                <a:solidFill>
+                  <a:srgbClr val="00D98B"/>
+                </a:solidFill>
+              </a:rPr>
+              <a:t>كلها ✓</a:t>
+            </a:r>
+          </a:p>
+        </p:txBody>
+      </p:sp>
+      <p:sp>
+        <p:nvSpPr>
+          <p:cNvPr id="10" name="Rounded Rectangle 9"/>
+          <p:cNvSpPr/>
+          <p:nvPr/>
+        </p:nvSpPr>
+        <p:spPr>
+          <a:xfrm>
+            <a:off x="822960" y="5010912"/>
+            <a:ext cx="10515600" cy="685800"/>
+          </a:xfrm>
+          <a:prstGeom prst="roundRect">
+            <a:avLst/>
+          </a:prstGeom>
+          <a:solidFill>
+            <a:srgbClr val="161B22"/>
+          </a:solidFill>
+          <a:ln>
+            <a:solidFill>
+              <a:srgbClr val="FFD166"/>
+            </a:solidFill>
+          </a:ln>
+          <a:effectLst/>
+        </p:spPr>
+        <p:style>
+          <a:lnRef idx="1">
+            <a:schemeClr val="accent1"/>
+          </a:lnRef>
+          <a:fillRef idx="3">
+            <a:schemeClr val="accent1"/>
+          </a:fillRef>
+          <a:effectRef idx="2">
+            <a:schemeClr val="accent1"/>
+          </a:effectRef>
+          <a:fontRef idx="minor">
+            <a:schemeClr val="lt1"/>
+          </a:fontRef>
+        </p:style>
+        <p:txBody>
+          <a:bodyPr rtlCol="0" anchor="ctr" wrap="square"/>
+          <a:lstStyle/>
+          <a:p>
+            <a:pPr algn="ctr"/>
+            <a:r>
+              <a:rPr sz="1500">
+                <a:solidFill>
+                  <a:srgbClr val="E6E6E6"/>
+                </a:solidFill>
+              </a:rPr>
+              <a:t>مطابقة ملف المتطلبات PDF (12 قسماً)</a:t>
+            </a:r>
+          </a:p>
+          <a:p>
+            <a:pPr algn="r"/>
+            <a:r>
+              <a:rPr sz="1500" b="1">
+                <a:solidFill>
+                  <a:srgbClr val="FFD166"/>
+                </a:solidFill>
+              </a:rPr>
+              <a:t>≈ 99.8 %</a:t>
+            </a:r>
+          </a:p>
+        </p:txBody>
+      </p:sp>
+    </p:spTree>
+  </p:cSld>
+  <p:clrMapOvr>
+    <a:masterClrMapping/>
+  </p:clrMapOvr>
+</p:sld>
+</file>
+
+<file path=ppt/slides/slide17.xml><?xml version="1.0" encoding="utf-8"?>
+<p:sld xmlns:a="http://schemas.openxmlformats.org/drawingml/2006/main" xmlns:p="http://schemas.openxmlformats.org/presentationml/2006/main" xmlns:r="http://schemas.openxmlformats.org/officeDocument/2006/relationships">
+  <p:cSld>
+    <p:spTree>
+      <p:nvGrpSpPr>
+        <p:cNvPr id="1" name=""/>
+        <p:cNvGrpSpPr/>
+        <p:nvPr/>
+      </p:nvGrpSpPr>
+      <p:grpSpPr/>
+      <p:sp>
+        <p:nvSpPr>
+          <p:cNvPr id="2" name="Rectangle 1"/>
+          <p:cNvSpPr/>
+          <p:nvPr/>
+        </p:nvSpPr>
+        <p:spPr>
+          <a:xfrm>
+            <a:off x="0" y="0"/>
+            <a:ext cx="12191695" cy="6858000"/>
+          </a:xfrm>
+          <a:prstGeom prst="rect">
+            <a:avLst/>
+          </a:prstGeom>
+          <a:solidFill>
+            <a:srgbClr val="0F1117"/>
+          </a:solidFill>
+          <a:ln>
+            <a:noFill/>
+          </a:ln>
+          <a:effectLst/>
+        </p:spPr>
+        <p:style>
+          <a:lnRef idx="1">
+            <a:schemeClr val="accent1"/>
+          </a:lnRef>
+          <a:fillRef idx="3">
+            <a:schemeClr val="accent1"/>
+          </a:fillRef>
+          <a:effectRef idx="2">
+            <a:schemeClr val="accent1"/>
+          </a:effectRef>
+          <a:fontRef idx="minor">
+            <a:schemeClr val="lt1"/>
+          </a:fontRef>
+        </p:style>
+        <p:txBody>
+          <a:bodyPr rtlCol="0" anchor="ctr"/>
+          <a:lstStyle/>
+          <a:p>
+            <a:pPr algn="ctr"/>
+          </a:p>
+        </p:txBody>
+      </p:sp>
+      <p:sp>
+        <p:nvSpPr>
+          <p:cNvPr id="3" name="TextBox 2"/>
+          <p:cNvSpPr txBox="1"/>
+          <p:nvPr/>
+        </p:nvSpPr>
+        <p:spPr>
+          <a:xfrm>
+            <a:off x="548640" y="292608"/>
+            <a:ext cx="11064240" cy="822960"/>
+          </a:xfrm>
+          <a:prstGeom prst="rect">
+            <a:avLst/>
+          </a:prstGeom>
+          <a:noFill/>
+        </p:spPr>
+        <p:txBody>
+          <a:bodyPr wrap="square" anchor="t">
+            <a:spAutoFit/>
+          </a:bodyPr>
+          <a:lstStyle/>
+          <a:p>
+            <a:pPr algn="l">
+              <a:spcAft>
+                <a:spcPts val="600"/>
+              </a:spcAft>
+            </a:pPr>
+            <a:r>
+              <a:rPr sz="2600" b="1">
+                <a:solidFill>
+                  <a:srgbClr val="00D98B"/>
+                </a:solidFill>
+                <a:latin typeface="Segoe UI"/>
+              </a:rPr>
               <a:t>الخلاصة</a:t>
             </a:r>
           </a:p>
@@ -7894,7 +8274,7 @@
                 </a:solidFill>
                 <a:latin typeface="Segoe UI"/>
               </a:rPr>
-              <a:t>إخفاء النصوص — LSB مع المفتاح</a:t>
+              <a:t>إخفاء النصوص — تقنيتان</a:t>
             </a:r>
           </a:p>
           <a:p>
@@ -7910,7 +8290,7 @@
                 </a:solidFill>
                 <a:latin typeface="Segoe UI"/>
               </a:rPr>
-              <a:t>Text Hiding — LSB with Key</a:t>
+              <a:t>Text Hiding — LSB with Key + Zero-Width</a:t>
             </a:r>
           </a:p>
         </p:txBody>
@@ -8045,7 +8425,7 @@
                 </a:solidFill>
                 <a:latin typeface="Segoe UI"/>
               </a:rPr>
-              <a:t>Python implementation داخل الأداة (بدل برنامج جاهز)</a:t>
+              <a:t>Python implementation داخل الأداة (بدل برنامج جاهز) — تقنيتان لكل موضوع</a:t>
             </a:r>
           </a:p>
         </p:txBody>
@@ -8122,7 +8502,7 @@
         </p:nvSpPr>
         <p:spPr>
           <a:xfrm>
-            <a:off x="731520" y="4"/>
+            <a:off x="731520" y="3"/>
             <a:ext cx="10698480" cy="768096"/>
           </a:xfrm>
           <a:prstGeom prst="rect">
@@ -8138,7 +8518,7 @@
           <a:p>
             <a:pPr algn="l">
               <a:spcAft>
-                <a:spcPts val="800"/>
+                <a:spcPts val="600"/>
               </a:spcAft>
             </a:pPr>
             <a:r>
@@ -8154,7 +8534,7 @@
           <a:p>
             <a:pPr algn="l">
               <a:spcAft>
-                <a:spcPts val="800"/>
+                <a:spcPts val="600"/>
               </a:spcAft>
             </a:pPr>
             <a:r>
@@ -8165,6 +8545,61 @@
                 <a:latin typeface="Segoe UI"/>
               </a:rPr>
               <a:t>• تبديل مواضع الحاملات مبني على المفتاح → بدون المفتاح لا يمكن إعادة التجميع (رفض المفتاح الخاطئ)</a:t>
+            </a:r>
+          </a:p>
+        </p:txBody>
+      </p:sp>
+      <p:sp>
+        <p:nvSpPr>
+          <p:cNvPr id="9" name="TextBox 8"/>
+          <p:cNvSpPr txBox="1"/>
+          <p:nvPr/>
+        </p:nvSpPr>
+        <p:spPr>
+          <a:xfrm>
+            <a:off x="731520" y="4"/>
+            <a:ext cx="10698480" cy="768096"/>
+          </a:xfrm>
+          <a:prstGeom prst="rect">
+            <a:avLst/>
+          </a:prstGeom>
+          <a:noFill/>
+        </p:spPr>
+        <p:txBody>
+          <a:bodyPr wrap="square" anchor="t">
+            <a:spAutoFit/>
+          </a:bodyPr>
+          <a:lstStyle/>
+          <a:p>
+            <a:pPr algn="l">
+              <a:spcAft>
+                <a:spcPts val="600"/>
+              </a:spcAft>
+            </a:pPr>
+            <a:r>
+              <a:rPr sz="1300" b="0">
+                <a:solidFill>
+                  <a:srgbClr val="E6E6E6"/>
+                </a:solidFill>
+                <a:latin typeface="Segoe UI"/>
+              </a:rPr>
+              <a:t>• التقنية الثانية (Zero-Width): أزواج البتات تُرمَّز بأحرف غير مرئية (U+200B/U+200C/U+200D/U+FEFF) موزعة داخل النص بتباعد مفتاحي — النص يبدو عادياً تماماً</a:t>
+            </a:r>
+          </a:p>
+          <a:p>
+            <a:pPr algn="l">
+              <a:spcAft>
+                <a:spcPts val="600"/>
+              </a:spcAft>
+            </a:pPr>
+            <a:r>
+              <a:rPr sz="1300" b="0">
+                <a:solidFill>
+                  <a:srgbClr val="E6E6E6"/>
+                </a:solidFill>
+                <a:latin typeface="Segoe UI"/>
+              </a:rPr>
+              <a:t>• الكشف: text-inspect يقرأ الأحرف غير المرئية ويكتشف الحمولة **بدون المفتاح**</a:t>
             </a:r>
           </a:p>
         </p:txBody>
@@ -8605,7 +9040,7 @@
                 </a:solidFill>
                 <a:latin typeface="Segoe UI"/>
               </a:rPr>
-              <a:t>إخفاء الصوت</a:t>
+              <a:t>أداة البيانات الوصفية — عرض وحقن</a:t>
             </a:r>
           </a:p>
           <a:p>
@@ -8621,7 +9056,7 @@
                 </a:solidFill>
                 <a:latin typeface="Segoe UI"/>
               </a:rPr>
-              <a:t>Audio Hiding</a:t>
+              <a:t>Metadata View &amp; Inject (requirement item 1)</a:t>
             </a:r>
           </a:p>
         </p:txBody>
@@ -8673,7 +9108,7 @@
                   <a:srgbClr val="08130D"/>
                 </a:solidFill>
               </a:rPr>
-              <a:t>06</a:t>
+              <a:t>05+</a:t>
             </a:r>
           </a:p>
         </p:txBody>
@@ -8722,151 +9157,9 @@
           </a:p>
         </p:txBody>
       </p:sp>
-      <p:sp>
-        <p:nvSpPr>
-          <p:cNvPr id="6" name="TextBox 5"/>
-          <p:cNvSpPr txBox="1"/>
-          <p:nvPr/>
-        </p:nvSpPr>
-        <p:spPr>
-          <a:xfrm>
-            <a:off x="731520" y="1371600"/>
-            <a:ext cx="10698480" cy="731520"/>
-          </a:xfrm>
-          <a:prstGeom prst="rect">
-            <a:avLst/>
-          </a:prstGeom>
-          <a:noFill/>
-        </p:spPr>
-        <p:txBody>
-          <a:bodyPr wrap="square" anchor="t">
-            <a:spAutoFit/>
-          </a:bodyPr>
-          <a:lstStyle/>
-          <a:p>
-            <a:pPr algn="l">
-              <a:spcAft>
-                <a:spcPts val="600"/>
-              </a:spcAft>
-            </a:pPr>
-            <a:r>
-              <a:rPr sz="1500" b="1">
-                <a:solidFill>
-                  <a:srgbClr val="E6E6E6"/>
-                </a:solidFill>
-                <a:latin typeface="Segoe UI"/>
-              </a:rPr>
-              <a:t>أربع تقنيات رئيسية (أكثر من تقنية في نفس الموضوع — حسب المتطلبات):</a:t>
-            </a:r>
-          </a:p>
-        </p:txBody>
-      </p:sp>
-      <p:sp>
-        <p:nvSpPr>
-          <p:cNvPr id="7" name="TextBox 6"/>
-          <p:cNvSpPr txBox="1"/>
-          <p:nvPr/>
-        </p:nvSpPr>
-        <p:spPr>
-          <a:xfrm>
-            <a:off x="731520" y="2"/>
-            <a:ext cx="10698480" cy="1920240"/>
-          </a:xfrm>
-          <a:prstGeom prst="rect">
-            <a:avLst/>
-          </a:prstGeom>
-          <a:noFill/>
-        </p:spPr>
-        <p:txBody>
-          <a:bodyPr wrap="square" anchor="t">
-            <a:spAutoFit/>
-          </a:bodyPr>
-          <a:lstStyle/>
-          <a:p>
-            <a:pPr algn="l">
-              <a:spcAft>
-                <a:spcPts val="800"/>
-              </a:spcAft>
-            </a:pPr>
-            <a:r>
-              <a:rPr sz="1400" b="0">
-                <a:solidFill>
-                  <a:srgbClr val="E6E6E6"/>
-                </a:solidFill>
-                <a:latin typeface="Segoe UI"/>
-              </a:rPr>
-              <a:t>• LSB  — إخفاء البيانات داخل Least Significant Bits لعينات الصوت (تبديل مواضع بالمفتاح)</a:t>
-            </a:r>
-          </a:p>
-          <a:p>
-            <a:pPr algn="l">
-              <a:spcAft>
-                <a:spcPts val="800"/>
-              </a:spcAft>
-            </a:pPr>
-            <a:r>
-              <a:rPr sz="1400" b="0">
-                <a:solidFill>
-                  <a:srgbClr val="E6E6E6"/>
-                </a:solidFill>
-                <a:latin typeface="Segoe UI"/>
-              </a:rPr>
-              <a:t>• Phase Coding  — تعديل معلومات الـ Phase (فرق ±π/2 بين إطارات FFT متتالية)</a:t>
-            </a:r>
-          </a:p>
-          <a:p>
-            <a:pPr algn="l">
-              <a:spcAft>
-                <a:spcPts val="800"/>
-              </a:spcAft>
-            </a:pPr>
-            <a:r>
-              <a:rPr sz="1400" b="0">
-                <a:solidFill>
-                  <a:srgbClr val="E6E6E6"/>
-                </a:solidFill>
-                <a:latin typeface="Segoe UI"/>
-              </a:rPr>
-              <a:t>• Spread Spectrum  — نشر البيانات على نطاق ترددات بدل موضع واحد (DSSS-BPSK)</a:t>
-            </a:r>
-          </a:p>
-          <a:p>
-            <a:pPr algn="l">
-              <a:spcAft>
-                <a:spcPts val="800"/>
-              </a:spcAft>
-            </a:pPr>
-            <a:r>
-              <a:rPr sz="1400" b="0">
-                <a:solidFill>
-                  <a:srgbClr val="E6E6E6"/>
-                </a:solidFill>
-                <a:latin typeface="Segoe UI"/>
-              </a:rPr>
-              <a:t>• Metadata  — إخفاء البيانات داخل الملف الصوتي دون تعديل العينات (RIFF LIST-INFO / ICMT)</a:t>
-            </a:r>
-          </a:p>
-          <a:p>
-            <a:pPr algn="l">
-              <a:spcAft>
-                <a:spcPts val="800"/>
-              </a:spcAft>
-            </a:pPr>
-            <a:r>
-              <a:rPr sz="1400" b="0">
-                <a:solidFill>
-                  <a:srgbClr val="E6E6E6"/>
-                </a:solidFill>
-                <a:latin typeface="Segoe UI"/>
-              </a:rPr>
-              <a:t>• التحليل: Steghide (للحالات التي يدعمها) + Spectrogram Frequency Analysis و Waveform (مخرجات Audacity)</a:t>
-            </a:r>
-          </a:p>
-        </p:txBody>
-      </p:sp>
       <p:pic>
         <p:nvPicPr>
-          <p:cNvPr id="8" name="Picture 7" descr="06_audio_hiding.png"/>
+          <p:cNvPr id="6" name="Picture 5" descr="05b_image_metadata.png"/>
           <p:cNvPicPr>
             <a:picLocks noChangeAspect="1"/>
           </p:cNvPicPr>
@@ -8880,14 +9173,309 @@
         </p:blipFill>
         <p:spPr>
           <a:xfrm>
-            <a:off x="731520" y="4709160"/>
-            <a:ext cx="5212080" cy="3248108"/>
+            <a:off x="502920" y="1325880"/>
+            <a:ext cx="6400800" cy="3988904"/>
           </a:xfrm>
           <a:prstGeom prst="rect">
             <a:avLst/>
           </a:prstGeom>
         </p:spPr>
       </p:pic>
+      <p:sp>
+        <p:nvSpPr>
+          <p:cNvPr id="7" name="TextBox 6"/>
+          <p:cNvSpPr txBox="1"/>
+          <p:nvPr/>
+        </p:nvSpPr>
+        <p:spPr>
+          <a:xfrm>
+            <a:off x="7223760" y="1463040"/>
+            <a:ext cx="4480560" cy="4937760"/>
+          </a:xfrm>
+          <a:prstGeom prst="rect">
+            <a:avLst/>
+          </a:prstGeom>
+          <a:noFill/>
+        </p:spPr>
+        <p:txBody>
+          <a:bodyPr wrap="square" anchor="t">
+            <a:spAutoFit/>
+          </a:bodyPr>
+          <a:lstStyle/>
+          <a:p>
+            <a:pPr algn="l">
+              <a:spcAft>
+                <a:spcPts val="600"/>
+              </a:spcAft>
+            </a:pPr>
+            <a:r>
+              <a:rPr sz="1500" b="1">
+                <a:solidFill>
+                  <a:srgbClr val="FFD166"/>
+                </a:solidFill>
+                <a:latin typeface="Segoe UI"/>
+              </a:rPr>
+              <a:t>المتطلب:</a:t>
+            </a:r>
+          </a:p>
+          <a:p>
+            <a:pPr algn="l">
+              <a:spcAft>
+                <a:spcPts val="600"/>
+              </a:spcAft>
+            </a:pPr>
+            <a:r>
+              <a:rPr sz="1400" b="0">
+                <a:solidFill>
+                  <a:srgbClr val="E6E6E6"/>
+                </a:solidFill>
+                <a:latin typeface="Segoe UI"/>
+              </a:rPr>
+              <a:t>أداة تعرض البيانات الوصفية وأيضاً أداة تحقنها</a:t>
+            </a:r>
+          </a:p>
+          <a:p>
+            <a:pPr algn="l">
+              <a:spcAft>
+                <a:spcPts val="600"/>
+              </a:spcAft>
+            </a:pPr>
+            <a:r>
+              <a:rPr sz="800" b="0">
+                <a:solidFill>
+                  <a:srgbClr val="E6E6E6"/>
+                </a:solidFill>
+                <a:latin typeface="Segoe UI"/>
+              </a:rPr>
+              <a:t/>
+            </a:r>
+          </a:p>
+          <a:p>
+            <a:pPr algn="l">
+              <a:spcAft>
+                <a:spcPts val="600"/>
+              </a:spcAft>
+            </a:pPr>
+            <a:r>
+              <a:rPr sz="1500" b="1">
+                <a:solidFill>
+                  <a:srgbClr val="00D98B"/>
+                </a:solidFill>
+                <a:latin typeface="Segoe UI"/>
+              </a:rPr>
+              <a:t>View:</a:t>
+            </a:r>
+          </a:p>
+          <a:p>
+            <a:pPr algn="l">
+              <a:spcAft>
+                <a:spcPts val="600"/>
+              </a:spcAft>
+            </a:pPr>
+            <a:r>
+              <a:rPr sz="1300" b="0">
+                <a:solidFill>
+                  <a:srgbClr val="E6E6E6"/>
+                </a:solidFill>
+                <a:latin typeface="Segoe UI"/>
+              </a:rPr>
+              <a:t>exiftool (Kali) لعرض كل حقول الملف مع بديل Pillow كامل</a:t>
+            </a:r>
+          </a:p>
+          <a:p>
+            <a:pPr algn="l">
+              <a:spcAft>
+                <a:spcPts val="600"/>
+              </a:spcAft>
+            </a:pPr>
+            <a:r>
+              <a:rPr sz="800" b="0">
+                <a:solidFill>
+                  <a:srgbClr val="E6E6E6"/>
+                </a:solidFill>
+                <a:latin typeface="Segoe UI"/>
+              </a:rPr>
+              <a:t/>
+            </a:r>
+          </a:p>
+          <a:p>
+            <a:pPr algn="l">
+              <a:spcAft>
+                <a:spcPts val="600"/>
+              </a:spcAft>
+            </a:pPr>
+            <a:r>
+              <a:rPr sz="1500" b="1">
+                <a:solidFill>
+                  <a:srgbClr val="00D98B"/>
+                </a:solidFill>
+                <a:latin typeface="Segoe UI"/>
+              </a:rPr>
+              <a:t>Inject:</a:t>
+            </a:r>
+          </a:p>
+          <a:p>
+            <a:pPr algn="l">
+              <a:spcAft>
+                <a:spcPts val="600"/>
+              </a:spcAft>
+            </a:pPr>
+            <a:r>
+              <a:rPr sz="1300" b="0">
+                <a:solidFill>
+                  <a:srgbClr val="E6E6E6"/>
+                </a:solidFill>
+                <a:latin typeface="Segoe UI"/>
+              </a:rPr>
+              <a:t>exiftool -Comment/-Artist مع -o (لا يُلمس الأصل أبداً) / PNG tEXt / JPEG COM</a:t>
+            </a:r>
+          </a:p>
+          <a:p>
+            <a:pPr algn="l">
+              <a:spcAft>
+                <a:spcPts val="600"/>
+              </a:spcAft>
+            </a:pPr>
+            <a:r>
+              <a:rPr sz="800" b="0">
+                <a:solidFill>
+                  <a:srgbClr val="E6E6E6"/>
+                </a:solidFill>
+                <a:latin typeface="Segoe UI"/>
+              </a:rPr>
+              <a:t/>
+            </a:r>
+          </a:p>
+          <a:p>
+            <a:pPr algn="l">
+              <a:spcAft>
+                <a:spcPts val="600"/>
+              </a:spcAft>
+            </a:pPr>
+            <a:r>
+              <a:rPr sz="1500" b="1">
+                <a:solidFill>
+                  <a:srgbClr val="00D98B"/>
+                </a:solidFill>
+                <a:latin typeface="Segoe UI"/>
+              </a:rPr>
+              <a:t>امتداد الصوت:</a:t>
+            </a:r>
+          </a:p>
+          <a:p>
+            <a:pPr algn="l">
+              <a:spcAft>
+                <a:spcPts val="600"/>
+              </a:spcAft>
+            </a:pPr>
+            <a:r>
+              <a:rPr sz="1300" b="0">
+                <a:solidFill>
+                  <a:srgbClr val="E6E6E6"/>
+                </a:solidFill>
+                <a:latin typeface="Segoe UI"/>
+              </a:rPr>
+              <a:t>حقن RIFF LIST-INFO (ICMT) عبر وحدة الصوت</a:t>
+            </a:r>
+          </a:p>
+          <a:p>
+            <a:pPr algn="l">
+              <a:spcAft>
+                <a:spcPts val="600"/>
+              </a:spcAft>
+            </a:pPr>
+            <a:r>
+              <a:rPr sz="800" b="0">
+                <a:solidFill>
+                  <a:srgbClr val="E6E6E6"/>
+                </a:solidFill>
+                <a:latin typeface="Segoe UI"/>
+              </a:rPr>
+              <a:t/>
+            </a:r>
+          </a:p>
+          <a:p>
+            <a:pPr algn="l">
+              <a:spcAft>
+                <a:spcPts val="600"/>
+              </a:spcAft>
+            </a:pPr>
+            <a:r>
+              <a:rPr sz="1500" b="1">
+                <a:solidFill>
+                  <a:srgbClr val="00D98B"/>
+                </a:solidFill>
+                <a:latin typeface="Segoe UI"/>
+              </a:rPr>
+              <a:t>تحقق فوري:</a:t>
+            </a:r>
+          </a:p>
+          <a:p>
+            <a:pPr algn="l">
+              <a:spcAft>
+                <a:spcPts val="600"/>
+              </a:spcAft>
+            </a:pPr>
+            <a:r>
+              <a:rPr sz="1300" b="0">
+                <a:solidFill>
+                  <a:srgbClr val="E6E6E6"/>
+                </a:solidFill>
+                <a:latin typeface="Segoe UI"/>
+              </a:rPr>
+              <a:t>إعادة قراءة البيانات بعد الحقن والتحقق من وجودها (verified)</a:t>
+            </a:r>
+          </a:p>
+          <a:p>
+            <a:pPr algn="l">
+              <a:spcAft>
+                <a:spcPts val="600"/>
+              </a:spcAft>
+            </a:pPr>
+            <a:r>
+              <a:rPr sz="800" b="0">
+                <a:solidFill>
+                  <a:srgbClr val="E6E6E6"/>
+                </a:solidFill>
+                <a:latin typeface="Segoe UI"/>
+              </a:rPr>
+              <a:t/>
+            </a:r>
+          </a:p>
+          <a:p>
+            <a:pPr algn="l">
+              <a:spcAft>
+                <a:spcPts val="600"/>
+              </a:spcAft>
+            </a:pPr>
+            <a:r>
+              <a:rPr sz="1500" b="1">
+                <a:solidFill>
+                  <a:srgbClr val="FFD166"/>
+                </a:solidFill>
+                <a:latin typeface="Segoe UI"/>
+              </a:rPr>
+              <a:t>CLI:</a:t>
+            </a:r>
+          </a:p>
+          <a:p>
+            <a:pPr algn="l">
+              <a:spcAft>
+                <a:spcPts val="600"/>
+              </a:spcAft>
+            </a:pPr>
+            <a:r>
+              <a:rPr sz="1400" b="0">
+                <a:solidFill>
+                  <a:srgbClr val="00D98B"/>
+                </a:solidFill>
+                <a:latin typeface="Segoe UI"/>
+              </a:rPr>
+              <a:t>image-meta view|inject</a:t>
+            </a:r>
+          </a:p>
+        </p:txBody>
+      </p:sp>
     </p:spTree>
   </p:cSld>
   <p:clrMapOvr>

</xml_diff>